<commit_message>
chore: bundle-size check and pitch deck refresh
Adds web/scripts/check-bundle.mjs, and commits the pending slide deck edits.
</commit_message>
<xml_diff>
--- a/slides/proofbench_pitch.pptx
+++ b/slides/proofbench_pitch.pptx
@@ -3092,6 +3092,14 @@
 <file path=ppt/slides/slide1.xml><?xml version="1.0" encoding="utf-8"?>
 <p:sld xmlns:a="http://schemas.openxmlformats.org/drawingml/2006/main" xmlns:p="http://schemas.openxmlformats.org/presentationml/2006/main" xmlns:r="http://schemas.openxmlformats.org/officeDocument/2006/relationships">
   <p:cSld>
+    <p:bg>
+      <p:bgPr>
+        <a:solidFill>
+          <a:srgbClr val="FCFCFE"/>
+        </a:solidFill>
+        <a:effectLst/>
+      </p:bgPr>
+    </p:bg>
     <p:spTree>
       <p:nvGrpSpPr>
         <p:cNvPr id="1" name=""/>
@@ -3108,50 +3116,6 @@
         <p:spPr>
           <a:xfrm>
             <a:off x="0" y="0"/>
-            <a:ext cx="12191695" cy="6858000"/>
-          </a:xfrm>
-          <a:prstGeom prst="rect">
-            <a:avLst/>
-          </a:prstGeom>
-          <a:solidFill>
-            <a:srgbClr val="FCFCFE"/>
-          </a:solidFill>
-          <a:ln>
-            <a:noFill/>
-          </a:ln>
-          <a:effectLst/>
-        </p:spPr>
-        <p:style>
-          <a:lnRef idx="1">
-            <a:schemeClr val="accent1"/>
-          </a:lnRef>
-          <a:fillRef idx="3">
-            <a:schemeClr val="accent1"/>
-          </a:fillRef>
-          <a:effectRef idx="2">
-            <a:schemeClr val="accent1"/>
-          </a:effectRef>
-          <a:fontRef idx="minor">
-            <a:schemeClr val="lt1"/>
-          </a:fontRef>
-        </p:style>
-        <p:txBody>
-          <a:bodyPr rtlCol="0" anchor="ctr" lIns="0" rIns="0" tIns="0" bIns="0"/>
-          <a:lstStyle/>
-          <a:p>
-            <a:pPr algn="ctr"/>
-          </a:p>
-        </p:txBody>
-      </p:sp>
-      <p:sp>
-        <p:nvSpPr>
-          <p:cNvPr id="3" name="Rectangle 2"/>
-          <p:cNvSpPr/>
-          <p:nvPr/>
-        </p:nvSpPr>
-        <p:spPr>
-          <a:xfrm>
-            <a:off x="0" y="0"/>
             <a:ext cx="1015974" cy="41148"/>
           </a:xfrm>
           <a:prstGeom prst="rect">
@@ -3189,7 +3153,7 @@
       </p:sp>
       <p:sp>
         <p:nvSpPr>
-          <p:cNvPr id="4" name="TextBox 3"/>
+          <p:cNvPr id="3" name="TextBox 2"/>
           <p:cNvSpPr txBox="1"/>
           <p:nvPr/>
         </p:nvSpPr>
@@ -3224,7 +3188,7 @@
       </p:sp>
       <p:sp>
         <p:nvSpPr>
-          <p:cNvPr id="5" name="TextBox 4"/>
+          <p:cNvPr id="4" name="TextBox 3"/>
           <p:cNvSpPr txBox="1"/>
           <p:nvPr/>
         </p:nvSpPr>
@@ -3259,7 +3223,7 @@
       </p:sp>
       <p:sp>
         <p:nvSpPr>
-          <p:cNvPr id="6" name="TextBox 5"/>
+          <p:cNvPr id="5" name="TextBox 4"/>
           <p:cNvSpPr txBox="1"/>
           <p:nvPr/>
         </p:nvSpPr>
@@ -3294,7 +3258,7 @@
       </p:sp>
       <p:sp>
         <p:nvSpPr>
-          <p:cNvPr id="7" name="TextBox 6"/>
+          <p:cNvPr id="6" name="TextBox 5"/>
           <p:cNvSpPr txBox="1"/>
           <p:nvPr/>
         </p:nvSpPr>
@@ -3342,7 +3306,7 @@
       </p:sp>
       <p:sp>
         <p:nvSpPr>
-          <p:cNvPr id="8" name="TextBox 7"/>
+          <p:cNvPr id="7" name="TextBox 6"/>
           <p:cNvSpPr txBox="1"/>
           <p:nvPr/>
         </p:nvSpPr>
@@ -3404,6 +3368,14 @@
 <file path=ppt/slides/slide10.xml><?xml version="1.0" encoding="utf-8"?>
 <p:sld xmlns:a="http://schemas.openxmlformats.org/drawingml/2006/main" xmlns:p="http://schemas.openxmlformats.org/presentationml/2006/main" xmlns:r="http://schemas.openxmlformats.org/officeDocument/2006/relationships">
   <p:cSld>
+    <p:bg>
+      <p:bgPr>
+        <a:solidFill>
+          <a:srgbClr val="FCFCFE"/>
+        </a:solidFill>
+        <a:effectLst/>
+      </p:bgPr>
+    </p:bg>
     <p:spTree>
       <p:nvGrpSpPr>
         <p:cNvPr id="1" name=""/>
@@ -3420,50 +3392,6 @@
         <p:spPr>
           <a:xfrm>
             <a:off x="0" y="0"/>
-            <a:ext cx="12191695" cy="6858000"/>
-          </a:xfrm>
-          <a:prstGeom prst="rect">
-            <a:avLst/>
-          </a:prstGeom>
-          <a:solidFill>
-            <a:srgbClr val="FCFCFE"/>
-          </a:solidFill>
-          <a:ln>
-            <a:noFill/>
-          </a:ln>
-          <a:effectLst/>
-        </p:spPr>
-        <p:style>
-          <a:lnRef idx="1">
-            <a:schemeClr val="accent1"/>
-          </a:lnRef>
-          <a:fillRef idx="3">
-            <a:schemeClr val="accent1"/>
-          </a:fillRef>
-          <a:effectRef idx="2">
-            <a:schemeClr val="accent1"/>
-          </a:effectRef>
-          <a:fontRef idx="minor">
-            <a:schemeClr val="lt1"/>
-          </a:fontRef>
-        </p:style>
-        <p:txBody>
-          <a:bodyPr rtlCol="0" anchor="ctr" lIns="0" rIns="0" tIns="0" bIns="0"/>
-          <a:lstStyle/>
-          <a:p>
-            <a:pPr algn="ctr"/>
-          </a:p>
-        </p:txBody>
-      </p:sp>
-      <p:sp>
-        <p:nvSpPr>
-          <p:cNvPr id="3" name="Rectangle 2"/>
-          <p:cNvSpPr/>
-          <p:nvPr/>
-        </p:nvSpPr>
-        <p:spPr>
-          <a:xfrm>
-            <a:off x="0" y="0"/>
             <a:ext cx="10159746" cy="41148"/>
           </a:xfrm>
           <a:prstGeom prst="rect">
@@ -3501,7 +3429,7 @@
       </p:sp>
       <p:sp>
         <p:nvSpPr>
-          <p:cNvPr id="4" name="TextBox 3"/>
+          <p:cNvPr id="3" name="TextBox 2"/>
           <p:cNvSpPr txBox="1"/>
           <p:nvPr/>
         </p:nvSpPr>
@@ -3536,7 +3464,7 @@
       </p:sp>
       <p:sp>
         <p:nvSpPr>
-          <p:cNvPr id="5" name="TextBox 4"/>
+          <p:cNvPr id="4" name="TextBox 3"/>
           <p:cNvSpPr txBox="1"/>
           <p:nvPr/>
         </p:nvSpPr>
@@ -3571,7 +3499,7 @@
       </p:sp>
       <p:sp>
         <p:nvSpPr>
-          <p:cNvPr id="6" name="TextBox 5"/>
+          <p:cNvPr id="5" name="TextBox 4"/>
           <p:cNvSpPr txBox="1"/>
           <p:nvPr/>
         </p:nvSpPr>
@@ -3610,7 +3538,7 @@
       </p:sp>
       <p:sp>
         <p:nvSpPr>
-          <p:cNvPr id="7" name="Rectangle 6"/>
+          <p:cNvPr id="6" name="Rectangle 5"/>
           <p:cNvSpPr/>
           <p:nvPr/>
         </p:nvSpPr>
@@ -3654,7 +3582,7 @@
       </p:sp>
       <p:sp>
         <p:nvSpPr>
-          <p:cNvPr id="8" name="TextBox 7"/>
+          <p:cNvPr id="7" name="TextBox 6"/>
           <p:cNvSpPr txBox="1"/>
           <p:nvPr/>
         </p:nvSpPr>
@@ -3689,7 +3617,7 @@
       </p:sp>
       <p:sp>
         <p:nvSpPr>
-          <p:cNvPr id="9" name="TextBox 8"/>
+          <p:cNvPr id="8" name="TextBox 7"/>
           <p:cNvSpPr txBox="1"/>
           <p:nvPr/>
         </p:nvSpPr>
@@ -3744,7 +3672,7 @@
       </p:sp>
       <p:sp>
         <p:nvSpPr>
-          <p:cNvPr id="10" name="Rectangle 9"/>
+          <p:cNvPr id="9" name="Rectangle 8"/>
           <p:cNvSpPr/>
           <p:nvPr/>
         </p:nvSpPr>
@@ -3788,7 +3716,7 @@
       </p:sp>
       <p:sp>
         <p:nvSpPr>
-          <p:cNvPr id="11" name="TextBox 10"/>
+          <p:cNvPr id="10" name="TextBox 9"/>
           <p:cNvSpPr txBox="1"/>
           <p:nvPr/>
         </p:nvSpPr>
@@ -3823,7 +3751,7 @@
       </p:sp>
       <p:sp>
         <p:nvSpPr>
-          <p:cNvPr id="12" name="TextBox 11"/>
+          <p:cNvPr id="11" name="TextBox 10"/>
           <p:cNvSpPr txBox="1"/>
           <p:nvPr/>
         </p:nvSpPr>
@@ -3878,7 +3806,7 @@
       </p:sp>
       <p:sp>
         <p:nvSpPr>
-          <p:cNvPr id="13" name="Rectangle 12"/>
+          <p:cNvPr id="12" name="Rectangle 11"/>
           <p:cNvSpPr/>
           <p:nvPr/>
         </p:nvSpPr>
@@ -3922,7 +3850,7 @@
       </p:sp>
       <p:sp>
         <p:nvSpPr>
-          <p:cNvPr id="14" name="TextBox 13"/>
+          <p:cNvPr id="13" name="TextBox 12"/>
           <p:cNvSpPr txBox="1"/>
           <p:nvPr/>
         </p:nvSpPr>
@@ -3957,7 +3885,7 @@
       </p:sp>
       <p:sp>
         <p:nvSpPr>
-          <p:cNvPr id="15" name="TextBox 14"/>
+          <p:cNvPr id="14" name="TextBox 13"/>
           <p:cNvSpPr txBox="1"/>
           <p:nvPr/>
         </p:nvSpPr>
@@ -4012,7 +3940,7 @@
       </p:sp>
       <p:sp>
         <p:nvSpPr>
-          <p:cNvPr id="16" name="Rectangle 15"/>
+          <p:cNvPr id="15" name="Rectangle 14"/>
           <p:cNvSpPr/>
           <p:nvPr/>
         </p:nvSpPr>
@@ -4056,7 +3984,7 @@
       </p:sp>
       <p:sp>
         <p:nvSpPr>
-          <p:cNvPr id="17" name="TextBox 16"/>
+          <p:cNvPr id="16" name="TextBox 15"/>
           <p:cNvSpPr txBox="1"/>
           <p:nvPr/>
         </p:nvSpPr>
@@ -4091,7 +4019,7 @@
       </p:sp>
       <p:sp>
         <p:nvSpPr>
-          <p:cNvPr id="18" name="TextBox 17"/>
+          <p:cNvPr id="17" name="TextBox 16"/>
           <p:cNvSpPr txBox="1"/>
           <p:nvPr/>
         </p:nvSpPr>
@@ -4146,7 +4074,7 @@
       </p:sp>
       <p:sp>
         <p:nvSpPr>
-          <p:cNvPr id="19" name="Rectangle 18"/>
+          <p:cNvPr id="18" name="Rectangle 17"/>
           <p:cNvSpPr/>
           <p:nvPr/>
         </p:nvSpPr>
@@ -4199,6 +4127,14 @@
 <file path=ppt/slides/slide11.xml><?xml version="1.0" encoding="utf-8"?>
 <p:sld xmlns:a="http://schemas.openxmlformats.org/drawingml/2006/main" xmlns:p="http://schemas.openxmlformats.org/presentationml/2006/main" xmlns:r="http://schemas.openxmlformats.org/officeDocument/2006/relationships">
   <p:cSld>
+    <p:bg>
+      <p:bgPr>
+        <a:solidFill>
+          <a:srgbClr val="FCFCFE"/>
+        </a:solidFill>
+        <a:effectLst/>
+      </p:bgPr>
+    </p:bg>
     <p:spTree>
       <p:nvGrpSpPr>
         <p:cNvPr id="1" name=""/>
@@ -4215,50 +4151,6 @@
         <p:spPr>
           <a:xfrm>
             <a:off x="0" y="0"/>
-            <a:ext cx="12191695" cy="6858000"/>
-          </a:xfrm>
-          <a:prstGeom prst="rect">
-            <a:avLst/>
-          </a:prstGeom>
-          <a:solidFill>
-            <a:srgbClr val="FCFCFE"/>
-          </a:solidFill>
-          <a:ln>
-            <a:noFill/>
-          </a:ln>
-          <a:effectLst/>
-        </p:spPr>
-        <p:style>
-          <a:lnRef idx="1">
-            <a:schemeClr val="accent1"/>
-          </a:lnRef>
-          <a:fillRef idx="3">
-            <a:schemeClr val="accent1"/>
-          </a:fillRef>
-          <a:effectRef idx="2">
-            <a:schemeClr val="accent1"/>
-          </a:effectRef>
-          <a:fontRef idx="minor">
-            <a:schemeClr val="lt1"/>
-          </a:fontRef>
-        </p:style>
-        <p:txBody>
-          <a:bodyPr rtlCol="0" anchor="ctr" lIns="0" rIns="0" tIns="0" bIns="0"/>
-          <a:lstStyle/>
-          <a:p>
-            <a:pPr algn="ctr"/>
-          </a:p>
-        </p:txBody>
-      </p:sp>
-      <p:sp>
-        <p:nvSpPr>
-          <p:cNvPr id="3" name="Rectangle 2"/>
-          <p:cNvSpPr/>
-          <p:nvPr/>
-        </p:nvSpPr>
-        <p:spPr>
-          <a:xfrm>
-            <a:off x="0" y="0"/>
             <a:ext cx="11175720" cy="41148"/>
           </a:xfrm>
           <a:prstGeom prst="rect">
@@ -4296,7 +4188,7 @@
       </p:sp>
       <p:sp>
         <p:nvSpPr>
-          <p:cNvPr id="4" name="TextBox 3"/>
+          <p:cNvPr id="3" name="TextBox 2"/>
           <p:cNvSpPr txBox="1"/>
           <p:nvPr/>
         </p:nvSpPr>
@@ -4331,7 +4223,7 @@
       </p:sp>
       <p:sp>
         <p:nvSpPr>
-          <p:cNvPr id="5" name="TextBox 4"/>
+          <p:cNvPr id="4" name="TextBox 3"/>
           <p:cNvSpPr txBox="1"/>
           <p:nvPr/>
         </p:nvSpPr>
@@ -4366,7 +4258,7 @@
       </p:sp>
       <p:sp>
         <p:nvSpPr>
-          <p:cNvPr id="6" name="TextBox 5"/>
+          <p:cNvPr id="5" name="TextBox 4"/>
           <p:cNvSpPr txBox="1"/>
           <p:nvPr/>
         </p:nvSpPr>
@@ -4405,7 +4297,7 @@
       </p:sp>
       <p:sp>
         <p:nvSpPr>
-          <p:cNvPr id="7" name="Rectangle 6"/>
+          <p:cNvPr id="6" name="Rectangle 5"/>
           <p:cNvSpPr/>
           <p:nvPr/>
         </p:nvSpPr>
@@ -4449,7 +4341,7 @@
       </p:sp>
       <p:sp>
         <p:nvSpPr>
-          <p:cNvPr id="8" name="TextBox 7"/>
+          <p:cNvPr id="7" name="TextBox 6"/>
           <p:cNvSpPr txBox="1"/>
           <p:nvPr/>
         </p:nvSpPr>
@@ -4484,7 +4376,7 @@
       </p:sp>
       <p:sp>
         <p:nvSpPr>
-          <p:cNvPr id="9" name="TextBox 8"/>
+          <p:cNvPr id="8" name="TextBox 7"/>
           <p:cNvSpPr txBox="1"/>
           <p:nvPr/>
         </p:nvSpPr>
@@ -4539,7 +4431,7 @@
       </p:sp>
       <p:sp>
         <p:nvSpPr>
-          <p:cNvPr id="10" name="Rectangle 9"/>
+          <p:cNvPr id="9" name="Rectangle 8"/>
           <p:cNvSpPr/>
           <p:nvPr/>
         </p:nvSpPr>
@@ -4583,7 +4475,7 @@
       </p:sp>
       <p:sp>
         <p:nvSpPr>
-          <p:cNvPr id="11" name="TextBox 10"/>
+          <p:cNvPr id="10" name="TextBox 9"/>
           <p:cNvSpPr txBox="1"/>
           <p:nvPr/>
         </p:nvSpPr>
@@ -4618,7 +4510,7 @@
       </p:sp>
       <p:sp>
         <p:nvSpPr>
-          <p:cNvPr id="12" name="TextBox 11"/>
+          <p:cNvPr id="11" name="TextBox 10"/>
           <p:cNvSpPr txBox="1"/>
           <p:nvPr/>
         </p:nvSpPr>
@@ -4673,7 +4565,7 @@
       </p:sp>
       <p:sp>
         <p:nvSpPr>
-          <p:cNvPr id="13" name="Rectangle 12"/>
+          <p:cNvPr id="12" name="Rectangle 11"/>
           <p:cNvSpPr/>
           <p:nvPr/>
         </p:nvSpPr>
@@ -4717,7 +4609,7 @@
       </p:sp>
       <p:sp>
         <p:nvSpPr>
-          <p:cNvPr id="14" name="TextBox 13"/>
+          <p:cNvPr id="13" name="TextBox 12"/>
           <p:cNvSpPr txBox="1"/>
           <p:nvPr/>
         </p:nvSpPr>
@@ -4752,7 +4644,7 @@
       </p:sp>
       <p:sp>
         <p:nvSpPr>
-          <p:cNvPr id="15" name="TextBox 14"/>
+          <p:cNvPr id="14" name="TextBox 13"/>
           <p:cNvSpPr txBox="1"/>
           <p:nvPr/>
         </p:nvSpPr>
@@ -4807,7 +4699,7 @@
       </p:sp>
       <p:sp>
         <p:nvSpPr>
-          <p:cNvPr id="16" name="Rectangle 15"/>
+          <p:cNvPr id="15" name="Rectangle 14"/>
           <p:cNvSpPr/>
           <p:nvPr/>
         </p:nvSpPr>
@@ -4851,7 +4743,7 @@
       </p:sp>
       <p:sp>
         <p:nvSpPr>
-          <p:cNvPr id="17" name="TextBox 16"/>
+          <p:cNvPr id="16" name="TextBox 15"/>
           <p:cNvSpPr txBox="1"/>
           <p:nvPr/>
         </p:nvSpPr>
@@ -4886,7 +4778,7 @@
       </p:sp>
       <p:sp>
         <p:nvSpPr>
-          <p:cNvPr id="18" name="TextBox 17"/>
+          <p:cNvPr id="17" name="TextBox 16"/>
           <p:cNvSpPr txBox="1"/>
           <p:nvPr/>
         </p:nvSpPr>
@@ -4941,7 +4833,7 @@
       </p:sp>
       <p:sp>
         <p:nvSpPr>
-          <p:cNvPr id="19" name="Rectangle 18"/>
+          <p:cNvPr id="18" name="Rectangle 17"/>
           <p:cNvSpPr/>
           <p:nvPr/>
         </p:nvSpPr>
@@ -4985,7 +4877,7 @@
       </p:sp>
       <p:sp>
         <p:nvSpPr>
-          <p:cNvPr id="20" name="TextBox 19"/>
+          <p:cNvPr id="19" name="TextBox 18"/>
           <p:cNvSpPr txBox="1"/>
           <p:nvPr/>
         </p:nvSpPr>
@@ -5020,7 +4912,7 @@
       </p:sp>
       <p:sp>
         <p:nvSpPr>
-          <p:cNvPr id="21" name="TextBox 20"/>
+          <p:cNvPr id="20" name="TextBox 19"/>
           <p:cNvSpPr txBox="1"/>
           <p:nvPr/>
         </p:nvSpPr>
@@ -5075,7 +4967,7 @@
       </p:sp>
       <p:sp>
         <p:nvSpPr>
-          <p:cNvPr id="22" name="Rectangle 21"/>
+          <p:cNvPr id="21" name="Rectangle 20"/>
           <p:cNvSpPr/>
           <p:nvPr/>
         </p:nvSpPr>
@@ -5128,6 +5020,14 @@
 <file path=ppt/slides/slide12.xml><?xml version="1.0" encoding="utf-8"?>
 <p:sld xmlns:a="http://schemas.openxmlformats.org/drawingml/2006/main" xmlns:p="http://schemas.openxmlformats.org/presentationml/2006/main" xmlns:r="http://schemas.openxmlformats.org/officeDocument/2006/relationships">
   <p:cSld>
+    <p:bg>
+      <p:bgPr>
+        <a:solidFill>
+          <a:srgbClr val="FCFCFE"/>
+        </a:solidFill>
+        <a:effectLst/>
+      </p:bgPr>
+    </p:bg>
     <p:spTree>
       <p:nvGrpSpPr>
         <p:cNvPr id="1" name=""/>
@@ -5144,50 +5044,6 @@
         <p:spPr>
           <a:xfrm>
             <a:off x="0" y="0"/>
-            <a:ext cx="12191695" cy="6858000"/>
-          </a:xfrm>
-          <a:prstGeom prst="rect">
-            <a:avLst/>
-          </a:prstGeom>
-          <a:solidFill>
-            <a:srgbClr val="FCFCFE"/>
-          </a:solidFill>
-          <a:ln>
-            <a:noFill/>
-          </a:ln>
-          <a:effectLst/>
-        </p:spPr>
-        <p:style>
-          <a:lnRef idx="1">
-            <a:schemeClr val="accent1"/>
-          </a:lnRef>
-          <a:fillRef idx="3">
-            <a:schemeClr val="accent1"/>
-          </a:fillRef>
-          <a:effectRef idx="2">
-            <a:schemeClr val="accent1"/>
-          </a:effectRef>
-          <a:fontRef idx="minor">
-            <a:schemeClr val="lt1"/>
-          </a:fontRef>
-        </p:style>
-        <p:txBody>
-          <a:bodyPr rtlCol="0" anchor="ctr" lIns="0" rIns="0" tIns="0" bIns="0"/>
-          <a:lstStyle/>
-          <a:p>
-            <a:pPr algn="ctr"/>
-          </a:p>
-        </p:txBody>
-      </p:sp>
-      <p:sp>
-        <p:nvSpPr>
-          <p:cNvPr id="3" name="Rectangle 2"/>
-          <p:cNvSpPr/>
-          <p:nvPr/>
-        </p:nvSpPr>
-        <p:spPr>
-          <a:xfrm>
-            <a:off x="0" y="0"/>
             <a:ext cx="12191695" cy="41148"/>
           </a:xfrm>
           <a:prstGeom prst="rect">
@@ -5225,7 +5081,7 @@
       </p:sp>
       <p:sp>
         <p:nvSpPr>
-          <p:cNvPr id="4" name="TextBox 3"/>
+          <p:cNvPr id="3" name="TextBox 2"/>
           <p:cNvSpPr txBox="1"/>
           <p:nvPr/>
         </p:nvSpPr>
@@ -5260,7 +5116,7 @@
       </p:sp>
       <p:sp>
         <p:nvSpPr>
-          <p:cNvPr id="5" name="TextBox 4"/>
+          <p:cNvPr id="4" name="TextBox 3"/>
           <p:cNvSpPr txBox="1"/>
           <p:nvPr/>
         </p:nvSpPr>
@@ -5295,7 +5151,7 @@
       </p:sp>
       <p:sp>
         <p:nvSpPr>
-          <p:cNvPr id="6" name="TextBox 5"/>
+          <p:cNvPr id="5" name="TextBox 4"/>
           <p:cNvSpPr txBox="1"/>
           <p:nvPr/>
         </p:nvSpPr>
@@ -5330,7 +5186,7 @@
       </p:sp>
       <p:sp>
         <p:nvSpPr>
-          <p:cNvPr id="7" name="TextBox 6"/>
+          <p:cNvPr id="6" name="TextBox 5"/>
           <p:cNvSpPr txBox="1"/>
           <p:nvPr/>
         </p:nvSpPr>
@@ -5378,7 +5234,7 @@
       </p:sp>
       <p:sp>
         <p:nvSpPr>
-          <p:cNvPr id="8" name="TextBox 7"/>
+          <p:cNvPr id="7" name="TextBox 6"/>
           <p:cNvSpPr txBox="1"/>
           <p:nvPr/>
         </p:nvSpPr>
@@ -5406,7 +5262,7 @@
                 </a:solidFill>
                 <a:latin typeface="Inter"/>
               </a:rPr>
-              <a:t>Built on        </a:t>
+              <a:t>Built with        </a:t>
             </a:r>
             <a:r>
               <a:rPr sz="1300" b="0">
@@ -5434,6 +5290,45 @@
                 <a:latin typeface="Inter"/>
               </a:rPr>
               <a:t>Doubleword</a:t>
+            </a:r>
+          </a:p>
+        </p:txBody>
+      </p:sp>
+      <p:sp>
+        <p:nvSpPr>
+          <p:cNvPr id="8" name="TextBox 7"/>
+          <p:cNvSpPr txBox="1"/>
+          <p:nvPr/>
+        </p:nvSpPr>
+        <p:spPr>
+          <a:xfrm>
+            <a:off x="841248" y="5715000"/>
+            <a:ext cx="10509199" cy="365760"/>
+          </a:xfrm>
+          <a:prstGeom prst="rect">
+            <a:avLst/>
+          </a:prstGeom>
+          <a:noFill/>
+        </p:spPr>
+        <p:txBody>
+          <a:bodyPr wrap="square" anchor="t" lIns="0" rIns="0" tIns="0" bIns="0">
+            <a:spAutoFit/>
+          </a:bodyPr>
+          <a:lstStyle/>
+          <a:p>
+            <a:pPr algn="l">
+              <a:lnSpc>
+                <a:spcPct val="120000"/>
+              </a:lnSpc>
+            </a:pPr>
+            <a:r>
+              <a:rPr sz="1100" b="0">
+                <a:solidFill>
+                  <a:srgbClr val="82868E"/>
+                </a:solidFill>
+                <a:latin typeface="Inter"/>
+              </a:rPr>
+              <a:t>Third-party names and trademarks identify integrations only and do not imply sponsorship, endorsement, partnership, or affiliation.</a:t>
             </a:r>
           </a:p>
         </p:txBody>
@@ -5449,6 +5344,14 @@
 <file path=ppt/slides/slide2.xml><?xml version="1.0" encoding="utf-8"?>
 <p:sld xmlns:a="http://schemas.openxmlformats.org/drawingml/2006/main" xmlns:p="http://schemas.openxmlformats.org/presentationml/2006/main" xmlns:r="http://schemas.openxmlformats.org/officeDocument/2006/relationships">
   <p:cSld>
+    <p:bg>
+      <p:bgPr>
+        <a:solidFill>
+          <a:srgbClr val="FCFCFE"/>
+        </a:solidFill>
+        <a:effectLst/>
+      </p:bgPr>
+    </p:bg>
     <p:spTree>
       <p:nvGrpSpPr>
         <p:cNvPr id="1" name=""/>
@@ -5465,50 +5368,6 @@
         <p:spPr>
           <a:xfrm>
             <a:off x="0" y="0"/>
-            <a:ext cx="12191695" cy="6858000"/>
-          </a:xfrm>
-          <a:prstGeom prst="rect">
-            <a:avLst/>
-          </a:prstGeom>
-          <a:solidFill>
-            <a:srgbClr val="FCFCFE"/>
-          </a:solidFill>
-          <a:ln>
-            <a:noFill/>
-          </a:ln>
-          <a:effectLst/>
-        </p:spPr>
-        <p:style>
-          <a:lnRef idx="1">
-            <a:schemeClr val="accent1"/>
-          </a:lnRef>
-          <a:fillRef idx="3">
-            <a:schemeClr val="accent1"/>
-          </a:fillRef>
-          <a:effectRef idx="2">
-            <a:schemeClr val="accent1"/>
-          </a:effectRef>
-          <a:fontRef idx="minor">
-            <a:schemeClr val="lt1"/>
-          </a:fontRef>
-        </p:style>
-        <p:txBody>
-          <a:bodyPr rtlCol="0" anchor="ctr" lIns="0" rIns="0" tIns="0" bIns="0"/>
-          <a:lstStyle/>
-          <a:p>
-            <a:pPr algn="ctr"/>
-          </a:p>
-        </p:txBody>
-      </p:sp>
-      <p:sp>
-        <p:nvSpPr>
-          <p:cNvPr id="3" name="Rectangle 2"/>
-          <p:cNvSpPr/>
-          <p:nvPr/>
-        </p:nvSpPr>
-        <p:spPr>
-          <a:xfrm>
-            <a:off x="0" y="0"/>
             <a:ext cx="2031949" cy="41148"/>
           </a:xfrm>
           <a:prstGeom prst="rect">
@@ -5546,7 +5405,7 @@
       </p:sp>
       <p:sp>
         <p:nvSpPr>
-          <p:cNvPr id="4" name="TextBox 3"/>
+          <p:cNvPr id="3" name="TextBox 2"/>
           <p:cNvSpPr txBox="1"/>
           <p:nvPr/>
         </p:nvSpPr>
@@ -5581,7 +5440,7 @@
       </p:sp>
       <p:sp>
         <p:nvSpPr>
-          <p:cNvPr id="5" name="TextBox 4"/>
+          <p:cNvPr id="4" name="TextBox 3"/>
           <p:cNvSpPr txBox="1"/>
           <p:nvPr/>
         </p:nvSpPr>
@@ -5616,7 +5475,7 @@
       </p:sp>
       <p:sp>
         <p:nvSpPr>
-          <p:cNvPr id="6" name="TextBox 5"/>
+          <p:cNvPr id="5" name="TextBox 4"/>
           <p:cNvSpPr txBox="1"/>
           <p:nvPr/>
         </p:nvSpPr>
@@ -5655,7 +5514,7 @@
       </p:sp>
       <p:sp>
         <p:nvSpPr>
-          <p:cNvPr id="7" name="Rectangle 6"/>
+          <p:cNvPr id="6" name="Rectangle 5"/>
           <p:cNvSpPr/>
           <p:nvPr/>
         </p:nvSpPr>
@@ -5699,7 +5558,7 @@
       </p:sp>
       <p:sp>
         <p:nvSpPr>
-          <p:cNvPr id="8" name="TextBox 7"/>
+          <p:cNvPr id="7" name="TextBox 6"/>
           <p:cNvSpPr txBox="1"/>
           <p:nvPr/>
         </p:nvSpPr>
@@ -5734,7 +5593,7 @@
       </p:sp>
       <p:sp>
         <p:nvSpPr>
-          <p:cNvPr id="9" name="TextBox 8"/>
+          <p:cNvPr id="8" name="TextBox 7"/>
           <p:cNvSpPr txBox="1"/>
           <p:nvPr/>
         </p:nvSpPr>
@@ -5789,7 +5648,7 @@
       </p:sp>
       <p:sp>
         <p:nvSpPr>
-          <p:cNvPr id="10" name="Rectangle 9"/>
+          <p:cNvPr id="9" name="Rectangle 8"/>
           <p:cNvSpPr/>
           <p:nvPr/>
         </p:nvSpPr>
@@ -5833,7 +5692,7 @@
       </p:sp>
       <p:sp>
         <p:nvSpPr>
-          <p:cNvPr id="11" name="TextBox 10"/>
+          <p:cNvPr id="10" name="TextBox 9"/>
           <p:cNvSpPr txBox="1"/>
           <p:nvPr/>
         </p:nvSpPr>
@@ -5868,7 +5727,7 @@
       </p:sp>
       <p:sp>
         <p:nvSpPr>
-          <p:cNvPr id="12" name="TextBox 11"/>
+          <p:cNvPr id="11" name="TextBox 10"/>
           <p:cNvSpPr txBox="1"/>
           <p:nvPr/>
         </p:nvSpPr>
@@ -5923,7 +5782,7 @@
       </p:sp>
       <p:sp>
         <p:nvSpPr>
-          <p:cNvPr id="13" name="Rectangle 12"/>
+          <p:cNvPr id="12" name="Rectangle 11"/>
           <p:cNvSpPr/>
           <p:nvPr/>
         </p:nvSpPr>
@@ -5967,7 +5826,7 @@
       </p:sp>
       <p:sp>
         <p:nvSpPr>
-          <p:cNvPr id="14" name="TextBox 13"/>
+          <p:cNvPr id="13" name="TextBox 12"/>
           <p:cNvSpPr txBox="1"/>
           <p:nvPr/>
         </p:nvSpPr>
@@ -6002,7 +5861,7 @@
       </p:sp>
       <p:sp>
         <p:nvSpPr>
-          <p:cNvPr id="15" name="TextBox 14"/>
+          <p:cNvPr id="14" name="TextBox 13"/>
           <p:cNvSpPr txBox="1"/>
           <p:nvPr/>
         </p:nvSpPr>
@@ -6057,7 +5916,7 @@
       </p:sp>
       <p:sp>
         <p:nvSpPr>
-          <p:cNvPr id="16" name="Rectangle 15"/>
+          <p:cNvPr id="15" name="Rectangle 14"/>
           <p:cNvSpPr/>
           <p:nvPr/>
         </p:nvSpPr>
@@ -6110,6 +5969,14 @@
 <file path=ppt/slides/slide3.xml><?xml version="1.0" encoding="utf-8"?>
 <p:sld xmlns:a="http://schemas.openxmlformats.org/drawingml/2006/main" xmlns:p="http://schemas.openxmlformats.org/presentationml/2006/main" xmlns:r="http://schemas.openxmlformats.org/officeDocument/2006/relationships">
   <p:cSld>
+    <p:bg>
+      <p:bgPr>
+        <a:solidFill>
+          <a:srgbClr val="FCFCFE"/>
+        </a:solidFill>
+        <a:effectLst/>
+      </p:bgPr>
+    </p:bg>
     <p:spTree>
       <p:nvGrpSpPr>
         <p:cNvPr id="1" name=""/>
@@ -6126,50 +5993,6 @@
         <p:spPr>
           <a:xfrm>
             <a:off x="0" y="0"/>
-            <a:ext cx="12191695" cy="6858000"/>
-          </a:xfrm>
-          <a:prstGeom prst="rect">
-            <a:avLst/>
-          </a:prstGeom>
-          <a:solidFill>
-            <a:srgbClr val="FCFCFE"/>
-          </a:solidFill>
-          <a:ln>
-            <a:noFill/>
-          </a:ln>
-          <a:effectLst/>
-        </p:spPr>
-        <p:style>
-          <a:lnRef idx="1">
-            <a:schemeClr val="accent1"/>
-          </a:lnRef>
-          <a:fillRef idx="3">
-            <a:schemeClr val="accent1"/>
-          </a:fillRef>
-          <a:effectRef idx="2">
-            <a:schemeClr val="accent1"/>
-          </a:effectRef>
-          <a:fontRef idx="minor">
-            <a:schemeClr val="lt1"/>
-          </a:fontRef>
-        </p:style>
-        <p:txBody>
-          <a:bodyPr rtlCol="0" anchor="ctr" lIns="0" rIns="0" tIns="0" bIns="0"/>
-          <a:lstStyle/>
-          <a:p>
-            <a:pPr algn="ctr"/>
-          </a:p>
-        </p:txBody>
-      </p:sp>
-      <p:sp>
-        <p:nvSpPr>
-          <p:cNvPr id="3" name="Rectangle 2"/>
-          <p:cNvSpPr/>
-          <p:nvPr/>
-        </p:nvSpPr>
-        <p:spPr>
-          <a:xfrm>
-            <a:off x="0" y="0"/>
             <a:ext cx="3047923" cy="41148"/>
           </a:xfrm>
           <a:prstGeom prst="rect">
@@ -6207,7 +6030,7 @@
       </p:sp>
       <p:sp>
         <p:nvSpPr>
-          <p:cNvPr id="4" name="TextBox 3"/>
+          <p:cNvPr id="3" name="TextBox 2"/>
           <p:cNvSpPr txBox="1"/>
           <p:nvPr/>
         </p:nvSpPr>
@@ -6242,7 +6065,7 @@
       </p:sp>
       <p:sp>
         <p:nvSpPr>
-          <p:cNvPr id="5" name="TextBox 4"/>
+          <p:cNvPr id="4" name="TextBox 3"/>
           <p:cNvSpPr txBox="1"/>
           <p:nvPr/>
         </p:nvSpPr>
@@ -6277,7 +6100,7 @@
       </p:sp>
       <p:sp>
         <p:nvSpPr>
-          <p:cNvPr id="6" name="TextBox 5"/>
+          <p:cNvPr id="5" name="TextBox 4"/>
           <p:cNvSpPr txBox="1"/>
           <p:nvPr/>
         </p:nvSpPr>
@@ -6316,7 +6139,7 @@
       </p:sp>
       <p:sp>
         <p:nvSpPr>
-          <p:cNvPr id="7" name="TextBox 6"/>
+          <p:cNvPr id="6" name="TextBox 5"/>
           <p:cNvSpPr txBox="1"/>
           <p:nvPr/>
         </p:nvSpPr>
@@ -6355,7 +6178,7 @@
       </p:sp>
       <p:sp>
         <p:nvSpPr>
-          <p:cNvPr id="8" name="TextBox 7"/>
+          <p:cNvPr id="7" name="TextBox 6"/>
           <p:cNvSpPr txBox="1"/>
           <p:nvPr/>
         </p:nvSpPr>
@@ -6403,6 +6226,14 @@
 <file path=ppt/slides/slide4.xml><?xml version="1.0" encoding="utf-8"?>
 <p:sld xmlns:a="http://schemas.openxmlformats.org/drawingml/2006/main" xmlns:p="http://schemas.openxmlformats.org/presentationml/2006/main" xmlns:r="http://schemas.openxmlformats.org/officeDocument/2006/relationships">
   <p:cSld>
+    <p:bg>
+      <p:bgPr>
+        <a:solidFill>
+          <a:srgbClr val="FCFCFE"/>
+        </a:solidFill>
+        <a:effectLst/>
+      </p:bgPr>
+    </p:bg>
     <p:spTree>
       <p:nvGrpSpPr>
         <p:cNvPr id="1" name=""/>
@@ -6419,50 +6250,6 @@
         <p:spPr>
           <a:xfrm>
             <a:off x="0" y="0"/>
-            <a:ext cx="12191695" cy="6858000"/>
-          </a:xfrm>
-          <a:prstGeom prst="rect">
-            <a:avLst/>
-          </a:prstGeom>
-          <a:solidFill>
-            <a:srgbClr val="FCFCFE"/>
-          </a:solidFill>
-          <a:ln>
-            <a:noFill/>
-          </a:ln>
-          <a:effectLst/>
-        </p:spPr>
-        <p:style>
-          <a:lnRef idx="1">
-            <a:schemeClr val="accent1"/>
-          </a:lnRef>
-          <a:fillRef idx="3">
-            <a:schemeClr val="accent1"/>
-          </a:fillRef>
-          <a:effectRef idx="2">
-            <a:schemeClr val="accent1"/>
-          </a:effectRef>
-          <a:fontRef idx="minor">
-            <a:schemeClr val="lt1"/>
-          </a:fontRef>
-        </p:style>
-        <p:txBody>
-          <a:bodyPr rtlCol="0" anchor="ctr" lIns="0" rIns="0" tIns="0" bIns="0"/>
-          <a:lstStyle/>
-          <a:p>
-            <a:pPr algn="ctr"/>
-          </a:p>
-        </p:txBody>
-      </p:sp>
-      <p:sp>
-        <p:nvSpPr>
-          <p:cNvPr id="3" name="Rectangle 2"/>
-          <p:cNvSpPr/>
-          <p:nvPr/>
-        </p:nvSpPr>
-        <p:spPr>
-          <a:xfrm>
-            <a:off x="0" y="0"/>
             <a:ext cx="4063898" cy="41148"/>
           </a:xfrm>
           <a:prstGeom prst="rect">
@@ -6500,7 +6287,7 @@
       </p:sp>
       <p:sp>
         <p:nvSpPr>
-          <p:cNvPr id="4" name="TextBox 3"/>
+          <p:cNvPr id="3" name="TextBox 2"/>
           <p:cNvSpPr txBox="1"/>
           <p:nvPr/>
         </p:nvSpPr>
@@ -6535,7 +6322,7 @@
       </p:sp>
       <p:sp>
         <p:nvSpPr>
-          <p:cNvPr id="5" name="TextBox 4"/>
+          <p:cNvPr id="4" name="TextBox 3"/>
           <p:cNvSpPr txBox="1"/>
           <p:nvPr/>
         </p:nvSpPr>
@@ -6570,7 +6357,7 @@
       </p:sp>
       <p:sp>
         <p:nvSpPr>
-          <p:cNvPr id="6" name="TextBox 5"/>
+          <p:cNvPr id="5" name="TextBox 4"/>
           <p:cNvSpPr txBox="1"/>
           <p:nvPr/>
         </p:nvSpPr>
@@ -6609,7 +6396,7 @@
       </p:sp>
       <p:sp>
         <p:nvSpPr>
-          <p:cNvPr id="7" name="TextBox 6"/>
+          <p:cNvPr id="6" name="TextBox 5"/>
           <p:cNvSpPr txBox="1"/>
           <p:nvPr/>
         </p:nvSpPr>
@@ -6666,7 +6453,7 @@
       </p:sp>
       <p:sp>
         <p:nvSpPr>
-          <p:cNvPr id="8" name="TextBox 7"/>
+          <p:cNvPr id="7" name="TextBox 6"/>
           <p:cNvSpPr txBox="1"/>
           <p:nvPr/>
         </p:nvSpPr>
@@ -6752,7 +6539,7 @@
       </p:sp>
       <p:sp>
         <p:nvSpPr>
-          <p:cNvPr id="9" name="Rectangle 8"/>
+          <p:cNvPr id="8" name="Rectangle 7"/>
           <p:cNvSpPr/>
           <p:nvPr/>
         </p:nvSpPr>
@@ -6796,7 +6583,7 @@
       </p:sp>
       <p:sp>
         <p:nvSpPr>
-          <p:cNvPr id="10" name="TextBox 9"/>
+          <p:cNvPr id="9" name="TextBox 8"/>
           <p:cNvSpPr txBox="1"/>
           <p:nvPr/>
         </p:nvSpPr>
@@ -6882,7 +6669,7 @@
       </p:sp>
       <p:sp>
         <p:nvSpPr>
-          <p:cNvPr id="11" name="Rectangle 10"/>
+          <p:cNvPr id="10" name="Rectangle 9"/>
           <p:cNvSpPr/>
           <p:nvPr/>
         </p:nvSpPr>
@@ -6926,7 +6713,7 @@
       </p:sp>
       <p:sp>
         <p:nvSpPr>
-          <p:cNvPr id="12" name="TextBox 11"/>
+          <p:cNvPr id="11" name="TextBox 10"/>
           <p:cNvSpPr txBox="1"/>
           <p:nvPr/>
         </p:nvSpPr>
@@ -7012,7 +6799,7 @@
       </p:sp>
       <p:sp>
         <p:nvSpPr>
-          <p:cNvPr id="13" name="Rectangle 12"/>
+          <p:cNvPr id="12" name="Rectangle 11"/>
           <p:cNvSpPr/>
           <p:nvPr/>
         </p:nvSpPr>
@@ -7056,7 +6843,7 @@
       </p:sp>
       <p:sp>
         <p:nvSpPr>
-          <p:cNvPr id="14" name="TextBox 13"/>
+          <p:cNvPr id="13" name="TextBox 12"/>
           <p:cNvSpPr txBox="1"/>
           <p:nvPr/>
         </p:nvSpPr>
@@ -7142,7 +6929,7 @@
       </p:sp>
       <p:sp>
         <p:nvSpPr>
-          <p:cNvPr id="15" name="Rectangle 14"/>
+          <p:cNvPr id="14" name="Rectangle 13"/>
           <p:cNvSpPr/>
           <p:nvPr/>
         </p:nvSpPr>
@@ -7186,7 +6973,7 @@
       </p:sp>
       <p:sp>
         <p:nvSpPr>
-          <p:cNvPr id="16" name="TextBox 15"/>
+          <p:cNvPr id="15" name="TextBox 14"/>
           <p:cNvSpPr txBox="1"/>
           <p:nvPr/>
         </p:nvSpPr>
@@ -7281,6 +7068,14 @@
 <file path=ppt/slides/slide5.xml><?xml version="1.0" encoding="utf-8"?>
 <p:sld xmlns:a="http://schemas.openxmlformats.org/drawingml/2006/main" xmlns:p="http://schemas.openxmlformats.org/presentationml/2006/main" xmlns:r="http://schemas.openxmlformats.org/officeDocument/2006/relationships">
   <p:cSld>
+    <p:bg>
+      <p:bgPr>
+        <a:solidFill>
+          <a:srgbClr val="FCFCFE"/>
+        </a:solidFill>
+        <a:effectLst/>
+      </p:bgPr>
+    </p:bg>
     <p:spTree>
       <p:nvGrpSpPr>
         <p:cNvPr id="1" name=""/>
@@ -7297,50 +7092,6 @@
         <p:spPr>
           <a:xfrm>
             <a:off x="0" y="0"/>
-            <a:ext cx="12191695" cy="6858000"/>
-          </a:xfrm>
-          <a:prstGeom prst="rect">
-            <a:avLst/>
-          </a:prstGeom>
-          <a:solidFill>
-            <a:srgbClr val="FCFCFE"/>
-          </a:solidFill>
-          <a:ln>
-            <a:noFill/>
-          </a:ln>
-          <a:effectLst/>
-        </p:spPr>
-        <p:style>
-          <a:lnRef idx="1">
-            <a:schemeClr val="accent1"/>
-          </a:lnRef>
-          <a:fillRef idx="3">
-            <a:schemeClr val="accent1"/>
-          </a:fillRef>
-          <a:effectRef idx="2">
-            <a:schemeClr val="accent1"/>
-          </a:effectRef>
-          <a:fontRef idx="minor">
-            <a:schemeClr val="lt1"/>
-          </a:fontRef>
-        </p:style>
-        <p:txBody>
-          <a:bodyPr rtlCol="0" anchor="ctr" lIns="0" rIns="0" tIns="0" bIns="0"/>
-          <a:lstStyle/>
-          <a:p>
-            <a:pPr algn="ctr"/>
-          </a:p>
-        </p:txBody>
-      </p:sp>
-      <p:sp>
-        <p:nvSpPr>
-          <p:cNvPr id="3" name="Rectangle 2"/>
-          <p:cNvSpPr/>
-          <p:nvPr/>
-        </p:nvSpPr>
-        <p:spPr>
-          <a:xfrm>
-            <a:off x="0" y="0"/>
             <a:ext cx="5079873" cy="41148"/>
           </a:xfrm>
           <a:prstGeom prst="rect">
@@ -7378,7 +7129,7 @@
       </p:sp>
       <p:sp>
         <p:nvSpPr>
-          <p:cNvPr id="4" name="TextBox 3"/>
+          <p:cNvPr id="3" name="TextBox 2"/>
           <p:cNvSpPr txBox="1"/>
           <p:nvPr/>
         </p:nvSpPr>
@@ -7413,7 +7164,7 @@
       </p:sp>
       <p:sp>
         <p:nvSpPr>
-          <p:cNvPr id="5" name="TextBox 4"/>
+          <p:cNvPr id="4" name="TextBox 3"/>
           <p:cNvSpPr txBox="1"/>
           <p:nvPr/>
         </p:nvSpPr>
@@ -7448,7 +7199,7 @@
       </p:sp>
       <p:sp>
         <p:nvSpPr>
-          <p:cNvPr id="6" name="TextBox 5"/>
+          <p:cNvPr id="5" name="TextBox 4"/>
           <p:cNvSpPr txBox="1"/>
           <p:nvPr/>
         </p:nvSpPr>
@@ -7480,14 +7231,14 @@
                 </a:solidFill>
                 <a:latin typeface="Inter"/>
               </a:rPr>
-              <a:t>Three sponsors, one pipeline.</a:t>
-            </a:r>
-          </a:p>
-        </p:txBody>
-      </p:sp>
-      <p:sp>
-        <p:nvSpPr>
-          <p:cNvPr id="7" name="Rectangle 6"/>
+              <a:t>Three integrations, one pipeline.</a:t>
+            </a:r>
+          </a:p>
+        </p:txBody>
+      </p:sp>
+      <p:sp>
+        <p:nvSpPr>
+          <p:cNvPr id="6" name="Rectangle 5"/>
           <p:cNvSpPr/>
           <p:nvPr/>
         </p:nvSpPr>
@@ -7531,7 +7282,7 @@
       </p:sp>
       <p:sp>
         <p:nvSpPr>
-          <p:cNvPr id="8" name="TextBox 7"/>
+          <p:cNvPr id="7" name="TextBox 6"/>
           <p:cNvSpPr txBox="1"/>
           <p:nvPr/>
         </p:nvSpPr>
@@ -7559,14 +7310,14 @@
                 </a:solidFill>
                 <a:latin typeface="Inter"/>
               </a:rPr>
-              <a:t>Sponsor</a:t>
-            </a:r>
-          </a:p>
-        </p:txBody>
-      </p:sp>
-      <p:sp>
-        <p:nvSpPr>
-          <p:cNvPr id="9" name="TextBox 8"/>
+              <a:t>Integration</a:t>
+            </a:r>
+          </a:p>
+        </p:txBody>
+      </p:sp>
+      <p:sp>
+        <p:nvSpPr>
+          <p:cNvPr id="8" name="TextBox 7"/>
           <p:cNvSpPr txBox="1"/>
           <p:nvPr/>
         </p:nvSpPr>
@@ -7601,7 +7352,7 @@
       </p:sp>
       <p:sp>
         <p:nvSpPr>
-          <p:cNvPr id="10" name="Rectangle 9"/>
+          <p:cNvPr id="9" name="Rectangle 8"/>
           <p:cNvSpPr/>
           <p:nvPr/>
         </p:nvSpPr>
@@ -7645,7 +7396,7 @@
       </p:sp>
       <p:sp>
         <p:nvSpPr>
-          <p:cNvPr id="11" name="TextBox 10"/>
+          <p:cNvPr id="10" name="TextBox 9"/>
           <p:cNvSpPr txBox="1"/>
           <p:nvPr/>
         </p:nvSpPr>
@@ -7680,7 +7431,7 @@
       </p:sp>
       <p:sp>
         <p:nvSpPr>
-          <p:cNvPr id="12" name="TextBox 11"/>
+          <p:cNvPr id="11" name="TextBox 10"/>
           <p:cNvSpPr txBox="1"/>
           <p:nvPr/>
         </p:nvSpPr>
@@ -7728,7 +7479,7 @@
       </p:sp>
       <p:sp>
         <p:nvSpPr>
-          <p:cNvPr id="13" name="Rectangle 12"/>
+          <p:cNvPr id="12" name="Rectangle 11"/>
           <p:cNvSpPr/>
           <p:nvPr/>
         </p:nvSpPr>
@@ -7772,7 +7523,7 @@
       </p:sp>
       <p:sp>
         <p:nvSpPr>
-          <p:cNvPr id="14" name="TextBox 13"/>
+          <p:cNvPr id="13" name="TextBox 12"/>
           <p:cNvSpPr txBox="1"/>
           <p:nvPr/>
         </p:nvSpPr>
@@ -7807,7 +7558,7 @@
       </p:sp>
       <p:sp>
         <p:nvSpPr>
-          <p:cNvPr id="15" name="TextBox 14"/>
+          <p:cNvPr id="14" name="TextBox 13"/>
           <p:cNvSpPr txBox="1"/>
           <p:nvPr/>
         </p:nvSpPr>
@@ -7855,7 +7606,7 @@
       </p:sp>
       <p:sp>
         <p:nvSpPr>
-          <p:cNvPr id="16" name="Rectangle 15"/>
+          <p:cNvPr id="15" name="Rectangle 14"/>
           <p:cNvSpPr/>
           <p:nvPr/>
         </p:nvSpPr>
@@ -7899,7 +7650,7 @@
       </p:sp>
       <p:sp>
         <p:nvSpPr>
-          <p:cNvPr id="17" name="TextBox 16"/>
+          <p:cNvPr id="16" name="TextBox 15"/>
           <p:cNvSpPr txBox="1"/>
           <p:nvPr/>
         </p:nvSpPr>
@@ -7934,7 +7685,7 @@
       </p:sp>
       <p:sp>
         <p:nvSpPr>
-          <p:cNvPr id="18" name="TextBox 17"/>
+          <p:cNvPr id="17" name="TextBox 16"/>
           <p:cNvSpPr txBox="1"/>
           <p:nvPr/>
         </p:nvSpPr>
@@ -7982,7 +7733,7 @@
       </p:sp>
       <p:sp>
         <p:nvSpPr>
-          <p:cNvPr id="19" name="Rectangle 18"/>
+          <p:cNvPr id="18" name="Rectangle 17"/>
           <p:cNvSpPr/>
           <p:nvPr/>
         </p:nvSpPr>
@@ -8021,6 +7772,45 @@
           <a:lstStyle/>
           <a:p>
             <a:pPr algn="ctr"/>
+          </a:p>
+        </p:txBody>
+      </p:sp>
+      <p:sp>
+        <p:nvSpPr>
+          <p:cNvPr id="19" name="TextBox 18"/>
+          <p:cNvSpPr txBox="1"/>
+          <p:nvPr/>
+        </p:nvSpPr>
+        <p:spPr>
+          <a:xfrm>
+            <a:off x="841248" y="5550407"/>
+            <a:ext cx="10509199" cy="365760"/>
+          </a:xfrm>
+          <a:prstGeom prst="rect">
+            <a:avLst/>
+          </a:prstGeom>
+          <a:noFill/>
+        </p:spPr>
+        <p:txBody>
+          <a:bodyPr wrap="square" anchor="t" lIns="0" rIns="0" tIns="0" bIns="0">
+            <a:spAutoFit/>
+          </a:bodyPr>
+          <a:lstStyle/>
+          <a:p>
+            <a:pPr algn="l">
+              <a:lnSpc>
+                <a:spcPct val="120000"/>
+              </a:lnSpc>
+            </a:pPr>
+            <a:r>
+              <a:rPr sz="1100" b="0">
+                <a:solidFill>
+                  <a:srgbClr val="82868E"/>
+                </a:solidFill>
+                <a:latin typeface="Inter"/>
+              </a:rPr>
+              <a:t>Third-party names and trademarks identify integrations only and do not imply sponsorship, endorsement, partnership, or affiliation.</a:t>
+            </a:r>
           </a:p>
         </p:txBody>
       </p:sp>
@@ -8035,6 +7825,14 @@
 <file path=ppt/slides/slide6.xml><?xml version="1.0" encoding="utf-8"?>
 <p:sld xmlns:a="http://schemas.openxmlformats.org/drawingml/2006/main" xmlns:p="http://schemas.openxmlformats.org/presentationml/2006/main" xmlns:r="http://schemas.openxmlformats.org/officeDocument/2006/relationships">
   <p:cSld>
+    <p:bg>
+      <p:bgPr>
+        <a:solidFill>
+          <a:srgbClr val="FCFCFE"/>
+        </a:solidFill>
+        <a:effectLst/>
+      </p:bgPr>
+    </p:bg>
     <p:spTree>
       <p:nvGrpSpPr>
         <p:cNvPr id="1" name=""/>
@@ -8051,50 +7849,6 @@
         <p:spPr>
           <a:xfrm>
             <a:off x="0" y="0"/>
-            <a:ext cx="12191695" cy="6858000"/>
-          </a:xfrm>
-          <a:prstGeom prst="rect">
-            <a:avLst/>
-          </a:prstGeom>
-          <a:solidFill>
-            <a:srgbClr val="FCFCFE"/>
-          </a:solidFill>
-          <a:ln>
-            <a:noFill/>
-          </a:ln>
-          <a:effectLst/>
-        </p:spPr>
-        <p:style>
-          <a:lnRef idx="1">
-            <a:schemeClr val="accent1"/>
-          </a:lnRef>
-          <a:fillRef idx="3">
-            <a:schemeClr val="accent1"/>
-          </a:fillRef>
-          <a:effectRef idx="2">
-            <a:schemeClr val="accent1"/>
-          </a:effectRef>
-          <a:fontRef idx="minor">
-            <a:schemeClr val="lt1"/>
-          </a:fontRef>
-        </p:style>
-        <p:txBody>
-          <a:bodyPr rtlCol="0" anchor="ctr" lIns="0" rIns="0" tIns="0" bIns="0"/>
-          <a:lstStyle/>
-          <a:p>
-            <a:pPr algn="ctr"/>
-          </a:p>
-        </p:txBody>
-      </p:sp>
-      <p:sp>
-        <p:nvSpPr>
-          <p:cNvPr id="3" name="Rectangle 2"/>
-          <p:cNvSpPr/>
-          <p:nvPr/>
-        </p:nvSpPr>
-        <p:spPr>
-          <a:xfrm>
-            <a:off x="0" y="0"/>
             <a:ext cx="6095847" cy="41148"/>
           </a:xfrm>
           <a:prstGeom prst="rect">
@@ -8132,7 +7886,7 @@
       </p:sp>
       <p:sp>
         <p:nvSpPr>
-          <p:cNvPr id="4" name="TextBox 3"/>
+          <p:cNvPr id="3" name="TextBox 2"/>
           <p:cNvSpPr txBox="1"/>
           <p:nvPr/>
         </p:nvSpPr>
@@ -8167,7 +7921,7 @@
       </p:sp>
       <p:sp>
         <p:nvSpPr>
-          <p:cNvPr id="5" name="TextBox 4"/>
+          <p:cNvPr id="4" name="TextBox 3"/>
           <p:cNvSpPr txBox="1"/>
           <p:nvPr/>
         </p:nvSpPr>
@@ -8202,7 +7956,7 @@
       </p:sp>
       <p:sp>
         <p:nvSpPr>
-          <p:cNvPr id="6" name="TextBox 5"/>
+          <p:cNvPr id="5" name="TextBox 4"/>
           <p:cNvSpPr txBox="1"/>
           <p:nvPr/>
         </p:nvSpPr>
@@ -8241,7 +7995,7 @@
       </p:sp>
       <p:sp>
         <p:nvSpPr>
-          <p:cNvPr id="7" name="TextBox 6"/>
+          <p:cNvPr id="6" name="TextBox 5"/>
           <p:cNvSpPr txBox="1"/>
           <p:nvPr/>
         </p:nvSpPr>
@@ -8298,7 +8052,7 @@
       </p:sp>
       <p:sp>
         <p:nvSpPr>
-          <p:cNvPr id="8" name="Rounded Rectangle 7"/>
+          <p:cNvPr id="7" name="Rounded Rectangle 6"/>
           <p:cNvSpPr/>
           <p:nvPr/>
         </p:nvSpPr>
@@ -8346,7 +8100,7 @@
       </p:sp>
       <p:sp>
         <p:nvSpPr>
-          <p:cNvPr id="9" name="TextBox 8"/>
+          <p:cNvPr id="8" name="TextBox 7"/>
           <p:cNvSpPr txBox="1"/>
           <p:nvPr/>
         </p:nvSpPr>
@@ -8381,7 +8135,7 @@
       </p:sp>
       <p:sp>
         <p:nvSpPr>
-          <p:cNvPr id="10" name="Rounded Rectangle 9"/>
+          <p:cNvPr id="9" name="Rounded Rectangle 8"/>
           <p:cNvSpPr/>
           <p:nvPr/>
         </p:nvSpPr>
@@ -8438,7 +8192,7 @@
       </p:sp>
       <p:sp>
         <p:nvSpPr>
-          <p:cNvPr id="11" name="Rounded Rectangle 10"/>
+          <p:cNvPr id="10" name="Rounded Rectangle 9"/>
           <p:cNvSpPr/>
           <p:nvPr/>
         </p:nvSpPr>
@@ -8495,7 +8249,7 @@
       </p:sp>
       <p:sp>
         <p:nvSpPr>
-          <p:cNvPr id="12" name="Rounded Rectangle 11"/>
+          <p:cNvPr id="11" name="Rounded Rectangle 10"/>
           <p:cNvSpPr/>
           <p:nvPr/>
         </p:nvSpPr>
@@ -8552,7 +8306,7 @@
       </p:sp>
       <p:sp>
         <p:nvSpPr>
-          <p:cNvPr id="13" name="Rounded Rectangle 12"/>
+          <p:cNvPr id="12" name="Rounded Rectangle 11"/>
           <p:cNvSpPr/>
           <p:nvPr/>
         </p:nvSpPr>
@@ -8609,7 +8363,7 @@
       </p:sp>
       <p:sp>
         <p:nvSpPr>
-          <p:cNvPr id="14" name="Rounded Rectangle 13"/>
+          <p:cNvPr id="13" name="Rounded Rectangle 12"/>
           <p:cNvSpPr/>
           <p:nvPr/>
         </p:nvSpPr>
@@ -8666,7 +8420,7 @@
       </p:sp>
       <p:sp>
         <p:nvSpPr>
-          <p:cNvPr id="15" name="Rectangle 14"/>
+          <p:cNvPr id="14" name="Rectangle 13"/>
           <p:cNvSpPr/>
           <p:nvPr/>
         </p:nvSpPr>
@@ -8710,7 +8464,7 @@
       </p:sp>
       <p:sp>
         <p:nvSpPr>
-          <p:cNvPr id="16" name="TextBox 15"/>
+          <p:cNvPr id="15" name="TextBox 14"/>
           <p:cNvSpPr txBox="1"/>
           <p:nvPr/>
         </p:nvSpPr>
@@ -8813,7 +8567,7 @@
       </p:sp>
       <p:sp>
         <p:nvSpPr>
-          <p:cNvPr id="17" name="Rounded Rectangle 16"/>
+          <p:cNvPr id="16" name="Rounded Rectangle 15"/>
           <p:cNvSpPr/>
           <p:nvPr/>
         </p:nvSpPr>
@@ -8877,6 +8631,14 @@
 <file path=ppt/slides/slide7.xml><?xml version="1.0" encoding="utf-8"?>
 <p:sld xmlns:a="http://schemas.openxmlformats.org/drawingml/2006/main" xmlns:p="http://schemas.openxmlformats.org/presentationml/2006/main" xmlns:r="http://schemas.openxmlformats.org/officeDocument/2006/relationships">
   <p:cSld>
+    <p:bg>
+      <p:bgPr>
+        <a:solidFill>
+          <a:srgbClr val="FCFCFE"/>
+        </a:solidFill>
+        <a:effectLst/>
+      </p:bgPr>
+    </p:bg>
     <p:spTree>
       <p:nvGrpSpPr>
         <p:cNvPr id="1" name=""/>
@@ -8893,50 +8655,6 @@
         <p:spPr>
           <a:xfrm>
             <a:off x="0" y="0"/>
-            <a:ext cx="12191695" cy="6858000"/>
-          </a:xfrm>
-          <a:prstGeom prst="rect">
-            <a:avLst/>
-          </a:prstGeom>
-          <a:solidFill>
-            <a:srgbClr val="FCFCFE"/>
-          </a:solidFill>
-          <a:ln>
-            <a:noFill/>
-          </a:ln>
-          <a:effectLst/>
-        </p:spPr>
-        <p:style>
-          <a:lnRef idx="1">
-            <a:schemeClr val="accent1"/>
-          </a:lnRef>
-          <a:fillRef idx="3">
-            <a:schemeClr val="accent1"/>
-          </a:fillRef>
-          <a:effectRef idx="2">
-            <a:schemeClr val="accent1"/>
-          </a:effectRef>
-          <a:fontRef idx="minor">
-            <a:schemeClr val="lt1"/>
-          </a:fontRef>
-        </p:style>
-        <p:txBody>
-          <a:bodyPr rtlCol="0" anchor="ctr" lIns="0" rIns="0" tIns="0" bIns="0"/>
-          <a:lstStyle/>
-          <a:p>
-            <a:pPr algn="ctr"/>
-          </a:p>
-        </p:txBody>
-      </p:sp>
-      <p:sp>
-        <p:nvSpPr>
-          <p:cNvPr id="3" name="Rectangle 2"/>
-          <p:cNvSpPr/>
-          <p:nvPr/>
-        </p:nvSpPr>
-        <p:spPr>
-          <a:xfrm>
-            <a:off x="0" y="0"/>
             <a:ext cx="7111822" cy="41148"/>
           </a:xfrm>
           <a:prstGeom prst="rect">
@@ -8974,7 +8692,7 @@
       </p:sp>
       <p:sp>
         <p:nvSpPr>
-          <p:cNvPr id="4" name="TextBox 3"/>
+          <p:cNvPr id="3" name="TextBox 2"/>
           <p:cNvSpPr txBox="1"/>
           <p:nvPr/>
         </p:nvSpPr>
@@ -9009,7 +8727,7 @@
       </p:sp>
       <p:sp>
         <p:nvSpPr>
-          <p:cNvPr id="5" name="TextBox 4"/>
+          <p:cNvPr id="4" name="TextBox 3"/>
           <p:cNvSpPr txBox="1"/>
           <p:nvPr/>
         </p:nvSpPr>
@@ -9044,7 +8762,7 @@
       </p:sp>
       <p:sp>
         <p:nvSpPr>
-          <p:cNvPr id="6" name="TextBox 5"/>
+          <p:cNvPr id="5" name="TextBox 4"/>
           <p:cNvSpPr txBox="1"/>
           <p:nvPr/>
         </p:nvSpPr>
@@ -9083,7 +8801,7 @@
       </p:sp>
       <p:sp>
         <p:nvSpPr>
-          <p:cNvPr id="7" name="TextBox 6"/>
+          <p:cNvPr id="6" name="TextBox 5"/>
           <p:cNvSpPr txBox="1"/>
           <p:nvPr/>
         </p:nvSpPr>
@@ -9177,7 +8895,7 @@
       </p:sp>
       <p:sp>
         <p:nvSpPr>
-          <p:cNvPr id="8" name="Rounded Rectangle 7"/>
+          <p:cNvPr id="7" name="Rounded Rectangle 6"/>
           <p:cNvSpPr/>
           <p:nvPr/>
         </p:nvSpPr>
@@ -9225,7 +8943,7 @@
       </p:sp>
       <p:sp>
         <p:nvSpPr>
-          <p:cNvPr id="9" name="TextBox 8"/>
+          <p:cNvPr id="8" name="TextBox 7"/>
           <p:cNvSpPr txBox="1"/>
           <p:nvPr/>
         </p:nvSpPr>
@@ -9419,6 +9137,14 @@
 <file path=ppt/slides/slide8.xml><?xml version="1.0" encoding="utf-8"?>
 <p:sld xmlns:a="http://schemas.openxmlformats.org/drawingml/2006/main" xmlns:p="http://schemas.openxmlformats.org/presentationml/2006/main" xmlns:r="http://schemas.openxmlformats.org/officeDocument/2006/relationships">
   <p:cSld>
+    <p:bg>
+      <p:bgPr>
+        <a:solidFill>
+          <a:srgbClr val="FCFCFE"/>
+        </a:solidFill>
+        <a:effectLst/>
+      </p:bgPr>
+    </p:bg>
     <p:spTree>
       <p:nvGrpSpPr>
         <p:cNvPr id="1" name=""/>
@@ -9435,50 +9161,6 @@
         <p:spPr>
           <a:xfrm>
             <a:off x="0" y="0"/>
-            <a:ext cx="12191695" cy="6858000"/>
-          </a:xfrm>
-          <a:prstGeom prst="rect">
-            <a:avLst/>
-          </a:prstGeom>
-          <a:solidFill>
-            <a:srgbClr val="FCFCFE"/>
-          </a:solidFill>
-          <a:ln>
-            <a:noFill/>
-          </a:ln>
-          <a:effectLst/>
-        </p:spPr>
-        <p:style>
-          <a:lnRef idx="1">
-            <a:schemeClr val="accent1"/>
-          </a:lnRef>
-          <a:fillRef idx="3">
-            <a:schemeClr val="accent1"/>
-          </a:fillRef>
-          <a:effectRef idx="2">
-            <a:schemeClr val="accent1"/>
-          </a:effectRef>
-          <a:fontRef idx="minor">
-            <a:schemeClr val="lt1"/>
-          </a:fontRef>
-        </p:style>
-        <p:txBody>
-          <a:bodyPr rtlCol="0" anchor="ctr" lIns="0" rIns="0" tIns="0" bIns="0"/>
-          <a:lstStyle/>
-          <a:p>
-            <a:pPr algn="ctr"/>
-          </a:p>
-        </p:txBody>
-      </p:sp>
-      <p:sp>
-        <p:nvSpPr>
-          <p:cNvPr id="3" name="Rectangle 2"/>
-          <p:cNvSpPr/>
-          <p:nvPr/>
-        </p:nvSpPr>
-        <p:spPr>
-          <a:xfrm>
-            <a:off x="0" y="0"/>
             <a:ext cx="8127796" cy="41148"/>
           </a:xfrm>
           <a:prstGeom prst="rect">
@@ -9516,7 +9198,7 @@
       </p:sp>
       <p:sp>
         <p:nvSpPr>
-          <p:cNvPr id="4" name="TextBox 3"/>
+          <p:cNvPr id="3" name="TextBox 2"/>
           <p:cNvSpPr txBox="1"/>
           <p:nvPr/>
         </p:nvSpPr>
@@ -9551,7 +9233,7 @@
       </p:sp>
       <p:sp>
         <p:nvSpPr>
-          <p:cNvPr id="5" name="TextBox 4"/>
+          <p:cNvPr id="4" name="TextBox 3"/>
           <p:cNvSpPr txBox="1"/>
           <p:nvPr/>
         </p:nvSpPr>
@@ -9586,7 +9268,7 @@
       </p:sp>
       <p:sp>
         <p:nvSpPr>
-          <p:cNvPr id="6" name="TextBox 5"/>
+          <p:cNvPr id="5" name="TextBox 4"/>
           <p:cNvSpPr txBox="1"/>
           <p:nvPr/>
         </p:nvSpPr>
@@ -9625,7 +9307,7 @@
       </p:sp>
       <p:sp>
         <p:nvSpPr>
-          <p:cNvPr id="7" name="TextBox 6"/>
+          <p:cNvPr id="6" name="TextBox 5"/>
           <p:cNvSpPr txBox="1"/>
           <p:nvPr/>
         </p:nvSpPr>
@@ -9682,7 +9364,7 @@
       </p:sp>
       <p:sp>
         <p:nvSpPr>
-          <p:cNvPr id="8" name="Rounded Rectangle 7"/>
+          <p:cNvPr id="7" name="Rounded Rectangle 6"/>
           <p:cNvSpPr/>
           <p:nvPr/>
         </p:nvSpPr>
@@ -9728,7 +9410,7 @@
       </p:sp>
       <p:sp>
         <p:nvSpPr>
-          <p:cNvPr id="9" name="TextBox 8"/>
+          <p:cNvPr id="8" name="TextBox 7"/>
           <p:cNvSpPr txBox="1"/>
           <p:nvPr/>
         </p:nvSpPr>
@@ -9964,6 +9646,14 @@
 <file path=ppt/slides/slide9.xml><?xml version="1.0" encoding="utf-8"?>
 <p:sld xmlns:a="http://schemas.openxmlformats.org/drawingml/2006/main" xmlns:p="http://schemas.openxmlformats.org/presentationml/2006/main" xmlns:r="http://schemas.openxmlformats.org/officeDocument/2006/relationships">
   <p:cSld>
+    <p:bg>
+      <p:bgPr>
+        <a:solidFill>
+          <a:srgbClr val="FCFCFE"/>
+        </a:solidFill>
+        <a:effectLst/>
+      </p:bgPr>
+    </p:bg>
     <p:spTree>
       <p:nvGrpSpPr>
         <p:cNvPr id="1" name=""/>
@@ -9980,50 +9670,6 @@
         <p:spPr>
           <a:xfrm>
             <a:off x="0" y="0"/>
-            <a:ext cx="12191695" cy="6858000"/>
-          </a:xfrm>
-          <a:prstGeom prst="rect">
-            <a:avLst/>
-          </a:prstGeom>
-          <a:solidFill>
-            <a:srgbClr val="FCFCFE"/>
-          </a:solidFill>
-          <a:ln>
-            <a:noFill/>
-          </a:ln>
-          <a:effectLst/>
-        </p:spPr>
-        <p:style>
-          <a:lnRef idx="1">
-            <a:schemeClr val="accent1"/>
-          </a:lnRef>
-          <a:fillRef idx="3">
-            <a:schemeClr val="accent1"/>
-          </a:fillRef>
-          <a:effectRef idx="2">
-            <a:schemeClr val="accent1"/>
-          </a:effectRef>
-          <a:fontRef idx="minor">
-            <a:schemeClr val="lt1"/>
-          </a:fontRef>
-        </p:style>
-        <p:txBody>
-          <a:bodyPr rtlCol="0" anchor="ctr" lIns="0" rIns="0" tIns="0" bIns="0"/>
-          <a:lstStyle/>
-          <a:p>
-            <a:pPr algn="ctr"/>
-          </a:p>
-        </p:txBody>
-      </p:sp>
-      <p:sp>
-        <p:nvSpPr>
-          <p:cNvPr id="3" name="Rectangle 2"/>
-          <p:cNvSpPr/>
-          <p:nvPr/>
-        </p:nvSpPr>
-        <p:spPr>
-          <a:xfrm>
-            <a:off x="0" y="0"/>
             <a:ext cx="9143771" cy="41148"/>
           </a:xfrm>
           <a:prstGeom prst="rect">
@@ -10061,7 +9707,7 @@
       </p:sp>
       <p:sp>
         <p:nvSpPr>
-          <p:cNvPr id="4" name="TextBox 3"/>
+          <p:cNvPr id="3" name="TextBox 2"/>
           <p:cNvSpPr txBox="1"/>
           <p:nvPr/>
         </p:nvSpPr>
@@ -10096,7 +9742,7 @@
       </p:sp>
       <p:sp>
         <p:nvSpPr>
-          <p:cNvPr id="5" name="TextBox 4"/>
+          <p:cNvPr id="4" name="TextBox 3"/>
           <p:cNvSpPr txBox="1"/>
           <p:nvPr/>
         </p:nvSpPr>
@@ -10131,7 +9777,7 @@
       </p:sp>
       <p:sp>
         <p:nvSpPr>
-          <p:cNvPr id="6" name="TextBox 5"/>
+          <p:cNvPr id="5" name="TextBox 4"/>
           <p:cNvSpPr txBox="1"/>
           <p:nvPr/>
         </p:nvSpPr>
@@ -10170,7 +9816,7 @@
       </p:sp>
       <p:sp>
         <p:nvSpPr>
-          <p:cNvPr id="7" name="TextBox 6"/>
+          <p:cNvPr id="6" name="TextBox 5"/>
           <p:cNvSpPr txBox="1"/>
           <p:nvPr/>
         </p:nvSpPr>
@@ -10218,7 +9864,7 @@
       </p:sp>
       <p:sp>
         <p:nvSpPr>
-          <p:cNvPr id="8" name="Rectangle 7"/>
+          <p:cNvPr id="7" name="Rectangle 6"/>
           <p:cNvSpPr/>
           <p:nvPr/>
         </p:nvSpPr>
@@ -10262,7 +9908,7 @@
       </p:sp>
       <p:sp>
         <p:nvSpPr>
-          <p:cNvPr id="9" name="TextBox 8"/>
+          <p:cNvPr id="8" name="TextBox 7"/>
           <p:cNvSpPr txBox="1"/>
           <p:nvPr/>
         </p:nvSpPr>
@@ -10306,7 +9952,7 @@
       </p:sp>
       <p:sp>
         <p:nvSpPr>
-          <p:cNvPr id="10" name="Rectangle 9"/>
+          <p:cNvPr id="9" name="Rectangle 8"/>
           <p:cNvSpPr/>
           <p:nvPr/>
         </p:nvSpPr>
@@ -10350,7 +9996,7 @@
       </p:sp>
       <p:sp>
         <p:nvSpPr>
-          <p:cNvPr id="11" name="TextBox 10"/>
+          <p:cNvPr id="10" name="TextBox 9"/>
           <p:cNvSpPr txBox="1"/>
           <p:nvPr/>
         </p:nvSpPr>
@@ -10394,7 +10040,7 @@
       </p:sp>
       <p:sp>
         <p:nvSpPr>
-          <p:cNvPr id="12" name="Rectangle 11"/>
+          <p:cNvPr id="11" name="Rectangle 10"/>
           <p:cNvSpPr/>
           <p:nvPr/>
         </p:nvSpPr>
@@ -10438,7 +10084,7 @@
       </p:sp>
       <p:sp>
         <p:nvSpPr>
-          <p:cNvPr id="13" name="TextBox 12"/>
+          <p:cNvPr id="12" name="TextBox 11"/>
           <p:cNvSpPr txBox="1"/>
           <p:nvPr/>
         </p:nvSpPr>
@@ -10482,7 +10128,7 @@
       </p:sp>
       <p:sp>
         <p:nvSpPr>
-          <p:cNvPr id="14" name="Rectangle 13"/>
+          <p:cNvPr id="13" name="Rectangle 12"/>
           <p:cNvSpPr/>
           <p:nvPr/>
         </p:nvSpPr>
@@ -10526,7 +10172,7 @@
       </p:sp>
       <p:sp>
         <p:nvSpPr>
-          <p:cNvPr id="15" name="Rounded Rectangle 14"/>
+          <p:cNvPr id="14" name="Rounded Rectangle 13"/>
           <p:cNvSpPr/>
           <p:nvPr/>
         </p:nvSpPr>
@@ -10574,7 +10220,7 @@
       </p:sp>
       <p:sp>
         <p:nvSpPr>
-          <p:cNvPr id="16" name="Rectangle 15"/>
+          <p:cNvPr id="15" name="Rectangle 14"/>
           <p:cNvSpPr/>
           <p:nvPr/>
         </p:nvSpPr>
@@ -10618,7 +10264,7 @@
       </p:sp>
       <p:sp>
         <p:nvSpPr>
-          <p:cNvPr id="17" name="TextBox 16"/>
+          <p:cNvPr id="16" name="TextBox 15"/>
           <p:cNvSpPr txBox="1"/>
           <p:nvPr/>
         </p:nvSpPr>
@@ -10653,7 +10299,7 @@
       </p:sp>
       <p:sp>
         <p:nvSpPr>
-          <p:cNvPr id="18" name="TextBox 17"/>
+          <p:cNvPr id="17" name="TextBox 16"/>
           <p:cNvSpPr txBox="1"/>
           <p:nvPr/>
         </p:nvSpPr>
@@ -10688,7 +10334,7 @@
       </p:sp>
       <p:sp>
         <p:nvSpPr>
-          <p:cNvPr id="19" name="TextBox 18"/>
+          <p:cNvPr id="18" name="TextBox 17"/>
           <p:cNvSpPr txBox="1"/>
           <p:nvPr/>
         </p:nvSpPr>
@@ -10723,7 +10369,7 @@
       </p:sp>
       <p:sp>
         <p:nvSpPr>
-          <p:cNvPr id="20" name="TextBox 19"/>
+          <p:cNvPr id="19" name="TextBox 18"/>
           <p:cNvSpPr txBox="1"/>
           <p:nvPr/>
         </p:nvSpPr>
@@ -10758,7 +10404,7 @@
       </p:sp>
       <p:sp>
         <p:nvSpPr>
-          <p:cNvPr id="21" name="TextBox 20"/>
+          <p:cNvPr id="20" name="TextBox 19"/>
           <p:cNvSpPr txBox="1"/>
           <p:nvPr/>
         </p:nvSpPr>
@@ -10793,7 +10439,7 @@
       </p:sp>
       <p:sp>
         <p:nvSpPr>
-          <p:cNvPr id="22" name="TextBox 21"/>
+          <p:cNvPr id="21" name="TextBox 20"/>
           <p:cNvSpPr txBox="1"/>
           <p:nvPr/>
         </p:nvSpPr>
@@ -10828,7 +10474,7 @@
       </p:sp>
       <p:sp>
         <p:nvSpPr>
-          <p:cNvPr id="23" name="TextBox 22"/>
+          <p:cNvPr id="22" name="TextBox 21"/>
           <p:cNvSpPr txBox="1"/>
           <p:nvPr/>
         </p:nvSpPr>
@@ -10863,7 +10509,7 @@
       </p:sp>
       <p:sp>
         <p:nvSpPr>
-          <p:cNvPr id="24" name="TextBox 23"/>
+          <p:cNvPr id="23" name="TextBox 22"/>
           <p:cNvSpPr txBox="1"/>
           <p:nvPr/>
         </p:nvSpPr>
@@ -10898,7 +10544,7 @@
       </p:sp>
       <p:sp>
         <p:nvSpPr>
-          <p:cNvPr id="25" name="Rectangle 24"/>
+          <p:cNvPr id="24" name="Rectangle 23"/>
           <p:cNvSpPr/>
           <p:nvPr/>
         </p:nvSpPr>
@@ -10942,7 +10588,7 @@
       </p:sp>
       <p:sp>
         <p:nvSpPr>
-          <p:cNvPr id="26" name="TextBox 25"/>
+          <p:cNvPr id="25" name="TextBox 24"/>
           <p:cNvSpPr txBox="1"/>
           <p:nvPr/>
         </p:nvSpPr>
@@ -10977,7 +10623,7 @@
       </p:sp>
       <p:sp>
         <p:nvSpPr>
-          <p:cNvPr id="27" name="TextBox 26"/>
+          <p:cNvPr id="26" name="TextBox 25"/>
           <p:cNvSpPr txBox="1"/>
           <p:nvPr/>
         </p:nvSpPr>
@@ -11012,7 +10658,7 @@
       </p:sp>
       <p:sp>
         <p:nvSpPr>
-          <p:cNvPr id="28" name="TextBox 27"/>
+          <p:cNvPr id="27" name="TextBox 26"/>
           <p:cNvSpPr txBox="1"/>
           <p:nvPr/>
         </p:nvSpPr>
@@ -11047,7 +10693,7 @@
       </p:sp>
       <p:sp>
         <p:nvSpPr>
-          <p:cNvPr id="29" name="TextBox 28"/>
+          <p:cNvPr id="28" name="TextBox 27"/>
           <p:cNvSpPr txBox="1"/>
           <p:nvPr/>
         </p:nvSpPr>
@@ -11082,7 +10728,7 @@
       </p:sp>
       <p:sp>
         <p:nvSpPr>
-          <p:cNvPr id="30" name="TextBox 29"/>
+          <p:cNvPr id="29" name="TextBox 28"/>
           <p:cNvSpPr txBox="1"/>
           <p:nvPr/>
         </p:nvSpPr>
@@ -11117,7 +10763,7 @@
       </p:sp>
       <p:sp>
         <p:nvSpPr>
-          <p:cNvPr id="31" name="TextBox 30"/>
+          <p:cNvPr id="30" name="TextBox 29"/>
           <p:cNvSpPr txBox="1"/>
           <p:nvPr/>
         </p:nvSpPr>
@@ -11152,7 +10798,7 @@
       </p:sp>
       <p:sp>
         <p:nvSpPr>
-          <p:cNvPr id="32" name="TextBox 31"/>
+          <p:cNvPr id="31" name="TextBox 30"/>
           <p:cNvSpPr txBox="1"/>
           <p:nvPr/>
         </p:nvSpPr>
@@ -11187,7 +10833,7 @@
       </p:sp>
       <p:sp>
         <p:nvSpPr>
-          <p:cNvPr id="33" name="TextBox 32"/>
+          <p:cNvPr id="32" name="TextBox 31"/>
           <p:cNvSpPr txBox="1"/>
           <p:nvPr/>
         </p:nvSpPr>
@@ -11222,7 +10868,7 @@
       </p:sp>
       <p:sp>
         <p:nvSpPr>
-          <p:cNvPr id="34" name="Rectangle 33"/>
+          <p:cNvPr id="33" name="Rectangle 32"/>
           <p:cNvSpPr/>
           <p:nvPr/>
         </p:nvSpPr>
@@ -11266,7 +10912,7 @@
       </p:sp>
       <p:sp>
         <p:nvSpPr>
-          <p:cNvPr id="35" name="TextBox 34"/>
+          <p:cNvPr id="34" name="TextBox 33"/>
           <p:cNvSpPr txBox="1"/>
           <p:nvPr/>
         </p:nvSpPr>
@@ -11301,7 +10947,7 @@
       </p:sp>
       <p:sp>
         <p:nvSpPr>
-          <p:cNvPr id="36" name="TextBox 35"/>
+          <p:cNvPr id="35" name="TextBox 34"/>
           <p:cNvSpPr txBox="1"/>
           <p:nvPr/>
         </p:nvSpPr>
@@ -11336,7 +10982,7 @@
       </p:sp>
       <p:sp>
         <p:nvSpPr>
-          <p:cNvPr id="37" name="TextBox 36"/>
+          <p:cNvPr id="36" name="TextBox 35"/>
           <p:cNvSpPr txBox="1"/>
           <p:nvPr/>
         </p:nvSpPr>
@@ -11371,7 +11017,7 @@
       </p:sp>
       <p:sp>
         <p:nvSpPr>
-          <p:cNvPr id="38" name="TextBox 37"/>
+          <p:cNvPr id="37" name="TextBox 36"/>
           <p:cNvSpPr txBox="1"/>
           <p:nvPr/>
         </p:nvSpPr>
@@ -11406,7 +11052,7 @@
       </p:sp>
       <p:sp>
         <p:nvSpPr>
-          <p:cNvPr id="39" name="TextBox 38"/>
+          <p:cNvPr id="38" name="TextBox 37"/>
           <p:cNvSpPr txBox="1"/>
           <p:nvPr/>
         </p:nvSpPr>
@@ -11441,7 +11087,7 @@
       </p:sp>
       <p:sp>
         <p:nvSpPr>
-          <p:cNvPr id="40" name="TextBox 39"/>
+          <p:cNvPr id="39" name="TextBox 38"/>
           <p:cNvSpPr txBox="1"/>
           <p:nvPr/>
         </p:nvSpPr>
@@ -11476,7 +11122,7 @@
       </p:sp>
       <p:sp>
         <p:nvSpPr>
-          <p:cNvPr id="41" name="TextBox 40"/>
+          <p:cNvPr id="40" name="TextBox 39"/>
           <p:cNvSpPr txBox="1"/>
           <p:nvPr/>
         </p:nvSpPr>
@@ -11511,7 +11157,7 @@
       </p:sp>
       <p:sp>
         <p:nvSpPr>
-          <p:cNvPr id="42" name="TextBox 41"/>
+          <p:cNvPr id="41" name="TextBox 40"/>
           <p:cNvSpPr txBox="1"/>
           <p:nvPr/>
         </p:nvSpPr>
@@ -11546,7 +11192,7 @@
       </p:sp>
       <p:sp>
         <p:nvSpPr>
-          <p:cNvPr id="43" name="Rectangle 42"/>
+          <p:cNvPr id="42" name="Rectangle 41"/>
           <p:cNvSpPr/>
           <p:nvPr/>
         </p:nvSpPr>
@@ -11590,7 +11236,7 @@
       </p:sp>
       <p:sp>
         <p:nvSpPr>
-          <p:cNvPr id="44" name="TextBox 43"/>
+          <p:cNvPr id="43" name="TextBox 42"/>
           <p:cNvSpPr txBox="1"/>
           <p:nvPr/>
         </p:nvSpPr>
@@ -11625,7 +11271,7 @@
       </p:sp>
       <p:sp>
         <p:nvSpPr>
-          <p:cNvPr id="45" name="TextBox 44"/>
+          <p:cNvPr id="44" name="TextBox 43"/>
           <p:cNvSpPr txBox="1"/>
           <p:nvPr/>
         </p:nvSpPr>
@@ -11660,7 +11306,7 @@
       </p:sp>
       <p:sp>
         <p:nvSpPr>
-          <p:cNvPr id="46" name="TextBox 45"/>
+          <p:cNvPr id="45" name="TextBox 44"/>
           <p:cNvSpPr txBox="1"/>
           <p:nvPr/>
         </p:nvSpPr>
@@ -11695,7 +11341,7 @@
       </p:sp>
       <p:sp>
         <p:nvSpPr>
-          <p:cNvPr id="47" name="TextBox 46"/>
+          <p:cNvPr id="46" name="TextBox 45"/>
           <p:cNvSpPr txBox="1"/>
           <p:nvPr/>
         </p:nvSpPr>
@@ -11730,7 +11376,7 @@
       </p:sp>
       <p:sp>
         <p:nvSpPr>
-          <p:cNvPr id="48" name="TextBox 47"/>
+          <p:cNvPr id="47" name="TextBox 46"/>
           <p:cNvSpPr txBox="1"/>
           <p:nvPr/>
         </p:nvSpPr>
@@ -11765,7 +11411,7 @@
       </p:sp>
       <p:sp>
         <p:nvSpPr>
-          <p:cNvPr id="49" name="TextBox 48"/>
+          <p:cNvPr id="48" name="TextBox 47"/>
           <p:cNvSpPr txBox="1"/>
           <p:nvPr/>
         </p:nvSpPr>
@@ -11800,7 +11446,7 @@
       </p:sp>
       <p:sp>
         <p:nvSpPr>
-          <p:cNvPr id="50" name="TextBox 49"/>
+          <p:cNvPr id="49" name="TextBox 48"/>
           <p:cNvSpPr txBox="1"/>
           <p:nvPr/>
         </p:nvSpPr>
@@ -11835,7 +11481,7 @@
       </p:sp>
       <p:sp>
         <p:nvSpPr>
-          <p:cNvPr id="51" name="TextBox 50"/>
+          <p:cNvPr id="50" name="TextBox 49"/>
           <p:cNvSpPr txBox="1"/>
           <p:nvPr/>
         </p:nvSpPr>
@@ -11870,7 +11516,7 @@
       </p:sp>
       <p:sp>
         <p:nvSpPr>
-          <p:cNvPr id="52" name="Rectangle 51"/>
+          <p:cNvPr id="51" name="Rectangle 50"/>
           <p:cNvSpPr/>
           <p:nvPr/>
         </p:nvSpPr>
@@ -11914,7 +11560,7 @@
       </p:sp>
       <p:sp>
         <p:nvSpPr>
-          <p:cNvPr id="53" name="TextBox 52"/>
+          <p:cNvPr id="52" name="TextBox 51"/>
           <p:cNvSpPr txBox="1"/>
           <p:nvPr/>
         </p:nvSpPr>
@@ -11949,7 +11595,7 @@
       </p:sp>
       <p:sp>
         <p:nvSpPr>
-          <p:cNvPr id="54" name="TextBox 53"/>
+          <p:cNvPr id="53" name="TextBox 52"/>
           <p:cNvSpPr txBox="1"/>
           <p:nvPr/>
         </p:nvSpPr>
@@ -11984,7 +11630,7 @@
       </p:sp>
       <p:sp>
         <p:nvSpPr>
-          <p:cNvPr id="55" name="TextBox 54"/>
+          <p:cNvPr id="54" name="TextBox 53"/>
           <p:cNvSpPr txBox="1"/>
           <p:nvPr/>
         </p:nvSpPr>
@@ -12019,7 +11665,7 @@
       </p:sp>
       <p:sp>
         <p:nvSpPr>
-          <p:cNvPr id="56" name="TextBox 55"/>
+          <p:cNvPr id="55" name="TextBox 54"/>
           <p:cNvSpPr txBox="1"/>
           <p:nvPr/>
         </p:nvSpPr>
@@ -12054,7 +11700,7 @@
       </p:sp>
       <p:sp>
         <p:nvSpPr>
-          <p:cNvPr id="57" name="TextBox 56"/>
+          <p:cNvPr id="56" name="TextBox 55"/>
           <p:cNvSpPr txBox="1"/>
           <p:nvPr/>
         </p:nvSpPr>
@@ -12089,7 +11735,7 @@
       </p:sp>
       <p:sp>
         <p:nvSpPr>
-          <p:cNvPr id="58" name="TextBox 57"/>
+          <p:cNvPr id="57" name="TextBox 56"/>
           <p:cNvSpPr txBox="1"/>
           <p:nvPr/>
         </p:nvSpPr>
@@ -12124,7 +11770,7 @@
       </p:sp>
       <p:sp>
         <p:nvSpPr>
-          <p:cNvPr id="59" name="TextBox 58"/>
+          <p:cNvPr id="58" name="TextBox 57"/>
           <p:cNvSpPr txBox="1"/>
           <p:nvPr/>
         </p:nvSpPr>
@@ -12159,7 +11805,7 @@
       </p:sp>
       <p:sp>
         <p:nvSpPr>
-          <p:cNvPr id="60" name="TextBox 59"/>
+          <p:cNvPr id="59" name="TextBox 58"/>
           <p:cNvSpPr txBox="1"/>
           <p:nvPr/>
         </p:nvSpPr>
@@ -12194,7 +11840,7 @@
       </p:sp>
       <p:sp>
         <p:nvSpPr>
-          <p:cNvPr id="61" name="TextBox 60"/>
+          <p:cNvPr id="60" name="TextBox 59"/>
           <p:cNvSpPr txBox="1"/>
           <p:nvPr/>
         </p:nvSpPr>

</xml_diff>